<commit_message>
Kafka: Arbeitsauftrag Fließtext mit Operatoren (Analysiere/Beurteile) auf Folie, Tafelbild und Tafelscript
Co-Authored-By: Claude Opus 5.5 <noreply@anthropic.com>
Claude-Session: https://claude.ai/code/session_01Kzh1oWiqhC6W8oSNq8mKnj
</commit_message>
<xml_diff>
--- a/Deutsch_11/Kafka_Brief_an_den_Vater/Praesentation_Kafka_Brief_an_den_Vater.pptx
+++ b/Deutsch_11/Kafka_Brief_an_den_Vater/Praesentation_Kafka_Brief_an_den_Vater.pptx
@@ -690,7 +690,7 @@
           <a:p>
             <a:r>
               <a:rPr lang="en-US" dirty="0"/>
-              <a:t>Timer 15 Minuten. Wer nach 5 Minuten keinen Anfang hat: nächste Folie (Musteranfang). Wer nicht fertig wird, schreibt zu Beginn der nächsten Stunde weiter – keine Hausaufgabe.</a:t>
+              <a:t>Operatoren kurz klären: Analysiere = untersuchen und geordnet, belegt darstellen; unter Berücksichtigung der Modelle = Fachbegriffe zur Erklärung nutzen; Beurteile abschließend, inwieweit = begründetes Urteil, auch „ja, aber“ ist möglich. Timer 15 Minuten. Wer nach 5 Minuten keinen Anfang hat: nächste Folie (Musteranfang). Wer nicht fertig wird, schreibt zu Beginn der nächsten Stunde weiter – keine Hausaufgabe.</a:t>
             </a:r>
             <a:endParaRPr lang="en-US" dirty="0"/>
           </a:p>
@@ -2771,14 +2771,129 @@
       </p:sp>
       <p:sp>
         <p:nvSpPr>
-          <p:cNvPr id="7" name="Text 5"/>
-          <p:cNvSpPr txBox="1"/>
-          <p:nvPr/>
-        </p:nvSpPr>
-        <p:spPr>
-          <a:xfrm>
-            <a:off x="548640" y="1234440"/>
-            <a:ext cx="10972800" cy="685800"/>
+          <p:cNvPr id="7" name="Shape 5"/>
+          <p:cNvSpPr/>
+          <p:nvPr/>
+        </p:nvSpPr>
+        <p:spPr>
+          <a:xfrm>
+            <a:off x="548640" y="1188720"/>
+            <a:ext cx="11064240" cy="1600200"/>
+          </a:xfrm>
+          <a:prstGeom prst="roundRect">
+            <a:avLst>
+              <a:gd name="adj" fmla="val 4571"/>
+            </a:avLst>
+          </a:prstGeom>
+          <a:solidFill>
+            <a:srgbClr val="F4F7FD"/>
+          </a:solidFill>
+          <a:ln/>
+        </p:spPr>
+      </p:sp>
+      <p:sp>
+        <p:nvSpPr>
+          <p:cNvPr id="8" name="Text 6"/>
+          <p:cNvSpPr txBox="1"/>
+          <p:nvPr/>
+        </p:nvSpPr>
+        <p:spPr>
+          <a:xfrm>
+            <a:off x="777240" y="1261872"/>
+            <a:ext cx="10607040" cy="1463040"/>
+          </a:xfrm>
+          <a:prstGeom prst="rect">
+            <a:avLst/>
+          </a:prstGeom>
+          <a:noFill/>
+          <a:ln/>
+        </p:spPr>
+        <p:txBody>
+          <a:bodyPr wrap="square" lIns="0" tIns="0" rIns="0" bIns="0" rtlCol="0" anchor="ctr"/>
+          <a:lstStyle/>
+          <a:p>
+            <a:pPr indent="0" marL="0">
+              <a:lnSpc>
+                <a:spcPct val="110000"/>
+              </a:lnSpc>
+              <a:buNone/>
+            </a:pPr>
+            <a:r>
+              <a:rPr lang="en-US" sz="1900" b="1" dirty="0">
+                <a:solidFill>
+                  <a:srgbClr val="D9534F"/>
+                </a:solidFill>
+                <a:latin typeface="Cambria" pitchFamily="34" charset="0"/>
+                <a:ea typeface="Cambria" pitchFamily="34" charset="-122"/>
+                <a:cs typeface="Cambria" pitchFamily="34" charset="-120"/>
+              </a:rPr>
+              <a:t>Analysiere</a:t>
+            </a:r>
+            <a:pPr indent="0" marL="0">
+              <a:lnSpc>
+                <a:spcPct val="110000"/>
+              </a:lnSpc>
+              <a:buNone/>
+            </a:pPr>
+            <a:r>
+              <a:rPr lang="en-US" sz="1900" dirty="0">
+                <a:solidFill>
+                  <a:srgbClr val="1E2761"/>
+                </a:solidFill>
+                <a:latin typeface="Cambria" pitchFamily="34" charset="0"/>
+                <a:ea typeface="Cambria" pitchFamily="34" charset="-122"/>
+                <a:cs typeface="Cambria" pitchFamily="34" charset="-120"/>
+              </a:rPr>
+              <a:t> die Kommunikation zwischen Vater und Sohn in den Abschnitten A und C aus Franz Kafkas „Brief an den Vater“ (1919) unter Berücksichtigung der Kommunikationsmodelle von Schulz von Thun und Watzlawick. </a:t>
+            </a:r>
+            <a:pPr indent="0" marL="0">
+              <a:lnSpc>
+                <a:spcPct val="110000"/>
+              </a:lnSpc>
+              <a:buNone/>
+            </a:pPr>
+            <a:r>
+              <a:rPr lang="en-US" sz="1900" b="1" dirty="0">
+                <a:solidFill>
+                  <a:srgbClr val="D9534F"/>
+                </a:solidFill>
+                <a:latin typeface="Cambria" pitchFamily="34" charset="0"/>
+                <a:ea typeface="Cambria" pitchFamily="34" charset="-122"/>
+                <a:cs typeface="Cambria" pitchFamily="34" charset="-120"/>
+              </a:rPr>
+              <a:t>Beurteile</a:t>
+            </a:r>
+            <a:pPr indent="0" marL="0">
+              <a:lnSpc>
+                <a:spcPct val="110000"/>
+              </a:lnSpc>
+              <a:buNone/>
+            </a:pPr>
+            <a:r>
+              <a:rPr lang="en-US" sz="1900" dirty="0">
+                <a:solidFill>
+                  <a:srgbClr val="1E2761"/>
+                </a:solidFill>
+                <a:latin typeface="Cambria" pitchFamily="34" charset="0"/>
+                <a:ea typeface="Cambria" pitchFamily="34" charset="-122"/>
+                <a:cs typeface="Cambria" pitchFamily="34" charset="-120"/>
+              </a:rPr>
+              <a:t> abschließend, inwieweit die These zutrifft, dass Kafkas „Furcht“ auf Kommunikationsproblemen gründet.</a:t>
+            </a:r>
+            <a:endParaRPr lang="en-US" sz="1900" dirty="0"/>
+          </a:p>
+        </p:txBody>
+      </p:sp>
+      <p:sp>
+        <p:nvSpPr>
+          <p:cNvPr id="9" name="Text 7"/>
+          <p:cNvSpPr txBox="1"/>
+          <p:nvPr/>
+        </p:nvSpPr>
+        <p:spPr>
+          <a:xfrm>
+            <a:off x="548640" y="2971800"/>
+            <a:ext cx="5486400" cy="411480"/>
           </a:xfrm>
           <a:prstGeom prst="rect">
             <a:avLst/>
@@ -2794,30 +2909,30 @@
               <a:buNone/>
             </a:pPr>
             <a:r>
-              <a:rPr lang="en-US" sz="2100" dirty="0">
+              <a:rPr lang="en-US" sz="1900" b="1" dirty="0">
                 <a:solidFill>
                   <a:srgbClr val="1E2761"/>
                 </a:solidFill>
-                <a:latin typeface="Calibri" pitchFamily="34" charset="0"/>
-                <a:ea typeface="Calibri" pitchFamily="34" charset="-122"/>
-                <a:cs typeface="Calibri" pitchFamily="34" charset="-120"/>
-              </a:rPr>
-              <a:t>Schreibe deine Analyse von A und C als zusammenhängenden Text in deinen Hefter – so wie in der Klausur.</a:t>
-            </a:r>
-            <a:endParaRPr lang="en-US" sz="2100" dirty="0"/>
-          </a:p>
-        </p:txBody>
-      </p:sp>
-      <p:sp>
-        <p:nvSpPr>
-          <p:cNvPr id="8" name="Shape 6"/>
+                <a:latin typeface="Cambria" pitchFamily="34" charset="0"/>
+                <a:ea typeface="Cambria" pitchFamily="34" charset="-122"/>
+                <a:cs typeface="Cambria" pitchFamily="34" charset="-120"/>
+              </a:rPr>
+              <a:t>So gehst du vor</a:t>
+            </a:r>
+            <a:endParaRPr lang="en-US" sz="1900" dirty="0"/>
+          </a:p>
+        </p:txBody>
+      </p:sp>
+      <p:sp>
+        <p:nvSpPr>
+          <p:cNvPr id="10" name="Shape 8"/>
           <p:cNvSpPr/>
           <p:nvPr/>
         </p:nvSpPr>
         <p:spPr>
           <a:xfrm>
-            <a:off x="548640" y="2194560"/>
-            <a:ext cx="2011680" cy="402336"/>
+            <a:off x="548640" y="3547872"/>
+            <a:ext cx="1600200" cy="402336"/>
           </a:xfrm>
           <a:prstGeom prst="roundRect">
             <a:avLst>
@@ -2832,14 +2947,14 @@
       </p:sp>
       <p:sp>
         <p:nvSpPr>
-          <p:cNvPr id="9" name="Text 7"/>
-          <p:cNvSpPr txBox="1"/>
-          <p:nvPr/>
-        </p:nvSpPr>
-        <p:spPr>
-          <a:xfrm>
-            <a:off x="548640" y="2194560"/>
-            <a:ext cx="2011680" cy="402336"/>
+          <p:cNvPr id="11" name="Text 9"/>
+          <p:cNvSpPr txBox="1"/>
+          <p:nvPr/>
+        </p:nvSpPr>
+        <p:spPr>
+          <a:xfrm>
+            <a:off x="548640" y="3547872"/>
+            <a:ext cx="1600200" cy="402336"/>
           </a:xfrm>
           <a:prstGeom prst="rect">
             <a:avLst/>
@@ -2855,7 +2970,7 @@
               <a:buNone/>
             </a:pPr>
             <a:r>
-              <a:rPr lang="en-US" sz="1600" b="1" dirty="0">
+              <a:rPr lang="en-US" sz="1400" b="1" dirty="0">
                 <a:solidFill>
                   <a:srgbClr val="FFFFFF"/>
                 </a:solidFill>
@@ -2865,20 +2980,20 @@
               </a:rPr>
               <a:t>Einleitung</a:t>
             </a:r>
-            <a:endParaRPr lang="en-US" sz="1600" dirty="0"/>
-          </a:p>
-        </p:txBody>
-      </p:sp>
-      <p:sp>
-        <p:nvSpPr>
-          <p:cNvPr id="10" name="Text 8"/>
-          <p:cNvSpPr txBox="1"/>
-          <p:nvPr/>
-        </p:nvSpPr>
-        <p:spPr>
-          <a:xfrm>
-            <a:off x="2788920" y="2103120"/>
-            <a:ext cx="8778240" cy="594360"/>
+            <a:endParaRPr lang="en-US" sz="1400" dirty="0"/>
+          </a:p>
+        </p:txBody>
+      </p:sp>
+      <p:sp>
+        <p:nvSpPr>
+          <p:cNvPr id="12" name="Text 10"/>
+          <p:cNvSpPr txBox="1"/>
+          <p:nvPr/>
+        </p:nvSpPr>
+        <p:spPr>
+          <a:xfrm>
+            <a:off x="2286000" y="3474720"/>
+            <a:ext cx="3749040" cy="566928"/>
           </a:xfrm>
           <a:prstGeom prst="rect">
             <a:avLst/>
@@ -2894,7 +3009,7 @@
               <a:buNone/>
             </a:pPr>
             <a:r>
-              <a:rPr lang="en-US" sz="1900" dirty="0">
+              <a:rPr lang="en-US" sz="1500" dirty="0">
                 <a:solidFill>
                   <a:srgbClr val="1E2761"/>
                 </a:solidFill>
@@ -2902,22 +3017,22 @@
                 <a:ea typeface="Calibri" pitchFamily="34" charset="-122"/>
                 <a:cs typeface="Calibri" pitchFamily="34" charset="-120"/>
               </a:rPr>
-              <a:t>Wer schreibt an wen, wann, worüber?</a:t>
-            </a:r>
-            <a:endParaRPr lang="en-US" sz="1900" dirty="0"/>
-          </a:p>
-        </p:txBody>
-      </p:sp>
-      <p:sp>
-        <p:nvSpPr>
-          <p:cNvPr id="11" name="Shape 9"/>
+              <a:t>Autor, Titel, Entstehungsjahr, Thema</a:t>
+            </a:r>
+            <a:endParaRPr lang="en-US" sz="1500" dirty="0"/>
+          </a:p>
+        </p:txBody>
+      </p:sp>
+      <p:sp>
+        <p:nvSpPr>
+          <p:cNvPr id="13" name="Shape 11"/>
           <p:cNvSpPr/>
           <p:nvPr/>
         </p:nvSpPr>
         <p:spPr>
           <a:xfrm>
-            <a:off x="548640" y="2926080"/>
-            <a:ext cx="2011680" cy="402336"/>
+            <a:off x="548640" y="4206240"/>
+            <a:ext cx="1600200" cy="402336"/>
           </a:xfrm>
           <a:prstGeom prst="roundRect">
             <a:avLst>
@@ -2932,14 +3047,14 @@
       </p:sp>
       <p:sp>
         <p:nvSpPr>
-          <p:cNvPr id="12" name="Text 10"/>
-          <p:cNvSpPr txBox="1"/>
-          <p:nvPr/>
-        </p:nvSpPr>
-        <p:spPr>
-          <a:xfrm>
-            <a:off x="548640" y="2926080"/>
-            <a:ext cx="2011680" cy="402336"/>
+          <p:cNvPr id="14" name="Text 12"/>
+          <p:cNvSpPr txBox="1"/>
+          <p:nvPr/>
+        </p:nvSpPr>
+        <p:spPr>
+          <a:xfrm>
+            <a:off x="548640" y="4206240"/>
+            <a:ext cx="1600200" cy="402336"/>
           </a:xfrm>
           <a:prstGeom prst="rect">
             <a:avLst/>
@@ -2955,7 +3070,7 @@
               <a:buNone/>
             </a:pPr>
             <a:r>
-              <a:rPr lang="en-US" sz="1600" b="1" dirty="0">
+              <a:rPr lang="en-US" sz="1400" b="1" dirty="0">
                 <a:solidFill>
                   <a:srgbClr val="FFFFFF"/>
                 </a:solidFill>
@@ -2965,20 +3080,20 @@
               </a:rPr>
               <a:t>Hauptteil</a:t>
             </a:r>
-            <a:endParaRPr lang="en-US" sz="1600" dirty="0"/>
-          </a:p>
-        </p:txBody>
-      </p:sp>
-      <p:sp>
-        <p:nvSpPr>
-          <p:cNvPr id="13" name="Text 11"/>
-          <p:cNvSpPr txBox="1"/>
-          <p:nvPr/>
-        </p:nvSpPr>
-        <p:spPr>
-          <a:xfrm>
-            <a:off x="2788920" y="2834640"/>
-            <a:ext cx="8778240" cy="594360"/>
+            <a:endParaRPr lang="en-US" sz="1400" dirty="0"/>
+          </a:p>
+        </p:txBody>
+      </p:sp>
+      <p:sp>
+        <p:nvSpPr>
+          <p:cNvPr id="15" name="Text 13"/>
+          <p:cNvSpPr txBox="1"/>
+          <p:nvPr/>
+        </p:nvSpPr>
+        <p:spPr>
+          <a:xfrm>
+            <a:off x="2286000" y="4133088"/>
+            <a:ext cx="3749040" cy="566928"/>
           </a:xfrm>
           <a:prstGeom prst="rect">
             <a:avLst/>
@@ -2994,7 +3109,7 @@
               <a:buNone/>
             </a:pPr>
             <a:r>
-              <a:rPr lang="en-US" sz="1900" dirty="0">
+              <a:rPr lang="en-US" sz="1500" dirty="0">
                 <a:solidFill>
                   <a:srgbClr val="1E2761"/>
                 </a:solidFill>
@@ -3002,22 +3117,22 @@
                 <a:ea typeface="Calibri" pitchFamily="34" charset="-122"/>
                 <a:cs typeface="Calibri" pitchFamily="34" charset="-120"/>
               </a:rPr>
-              <a:t>je Zeile der Matrix: Behauptung → Beleg (Zitat + Z.) → Erklärung · erst A, dann C</a:t>
-            </a:r>
-            <a:endParaRPr lang="en-US" sz="1900" dirty="0"/>
-          </a:p>
-        </p:txBody>
-      </p:sp>
-      <p:sp>
-        <p:nvSpPr>
-          <p:cNvPr id="14" name="Shape 12"/>
+              <a:t>je Zeile der Matrix: Behauptung → Beleg → Erklärung · erst A, dann C</a:t>
+            </a:r>
+            <a:endParaRPr lang="en-US" sz="1500" dirty="0"/>
+          </a:p>
+        </p:txBody>
+      </p:sp>
+      <p:sp>
+        <p:nvSpPr>
+          <p:cNvPr id="16" name="Shape 14"/>
           <p:cNvSpPr/>
           <p:nvPr/>
         </p:nvSpPr>
         <p:spPr>
           <a:xfrm>
-            <a:off x="548640" y="3657600"/>
-            <a:ext cx="2011680" cy="402336"/>
+            <a:off x="548640" y="4864608"/>
+            <a:ext cx="1600200" cy="402336"/>
           </a:xfrm>
           <a:prstGeom prst="roundRect">
             <a:avLst>
@@ -3032,14 +3147,14 @@
       </p:sp>
       <p:sp>
         <p:nvSpPr>
-          <p:cNvPr id="15" name="Text 13"/>
-          <p:cNvSpPr txBox="1"/>
-          <p:nvPr/>
-        </p:nvSpPr>
-        <p:spPr>
-          <a:xfrm>
-            <a:off x="548640" y="3657600"/>
-            <a:ext cx="2011680" cy="402336"/>
+          <p:cNvPr id="17" name="Text 15"/>
+          <p:cNvSpPr txBox="1"/>
+          <p:nvPr/>
+        </p:nvSpPr>
+        <p:spPr>
+          <a:xfrm>
+            <a:off x="548640" y="4864608"/>
+            <a:ext cx="1600200" cy="402336"/>
           </a:xfrm>
           <a:prstGeom prst="rect">
             <a:avLst/>
@@ -3055,7 +3170,7 @@
               <a:buNone/>
             </a:pPr>
             <a:r>
-              <a:rPr lang="en-US" sz="1600" b="1" dirty="0">
+              <a:rPr lang="en-US" sz="1400" b="1" dirty="0">
                 <a:solidFill>
                   <a:srgbClr val="FFFFFF"/>
                 </a:solidFill>
@@ -3065,20 +3180,20 @@
               </a:rPr>
               <a:t>Schluss</a:t>
             </a:r>
-            <a:endParaRPr lang="en-US" sz="1600" dirty="0"/>
-          </a:p>
-        </p:txBody>
-      </p:sp>
-      <p:sp>
-        <p:nvSpPr>
-          <p:cNvPr id="16" name="Text 14"/>
-          <p:cNvSpPr txBox="1"/>
-          <p:nvPr/>
-        </p:nvSpPr>
-        <p:spPr>
-          <a:xfrm>
-            <a:off x="2788920" y="3566160"/>
-            <a:ext cx="8778240" cy="594360"/>
+            <a:endParaRPr lang="en-US" sz="1400" dirty="0"/>
+          </a:p>
+        </p:txBody>
+      </p:sp>
+      <p:sp>
+        <p:nvSpPr>
+          <p:cNvPr id="18" name="Text 16"/>
+          <p:cNvSpPr txBox="1"/>
+          <p:nvPr/>
+        </p:nvSpPr>
+        <p:spPr>
+          <a:xfrm>
+            <a:off x="2286000" y="4791456"/>
+            <a:ext cx="3749040" cy="566928"/>
           </a:xfrm>
           <a:prstGeom prst="rect">
             <a:avLst/>
@@ -3094,7 +3209,7 @@
               <a:buNone/>
             </a:pPr>
             <a:r>
-              <a:rPr lang="en-US" sz="1900" dirty="0">
+              <a:rPr lang="en-US" sz="1500" dirty="0">
                 <a:solidFill>
                   <a:srgbClr val="1E2761"/>
                 </a:solidFill>
@@ -3102,26 +3217,65 @@
                 <a:ea typeface="Calibri" pitchFamily="34" charset="-122"/>
                 <a:cs typeface="Calibri" pitchFamily="34" charset="-120"/>
               </a:rPr>
-              <a:t>Stützen die Stellen die These? Was muss man ergänzen?</a:t>
-            </a:r>
-            <a:endParaRPr lang="en-US" sz="1900" dirty="0"/>
-          </a:p>
-        </p:txBody>
-      </p:sp>
-      <p:sp>
-        <p:nvSpPr>
-          <p:cNvPr id="17" name="Shape 15"/>
+              <a:t>begründetes Urteil zur These (auch „ja, aber …“)</a:t>
+            </a:r>
+            <a:endParaRPr lang="en-US" sz="1500" dirty="0"/>
+          </a:p>
+        </p:txBody>
+      </p:sp>
+      <p:sp>
+        <p:nvSpPr>
+          <p:cNvPr id="19" name="Text 17"/>
+          <p:cNvSpPr txBox="1"/>
+          <p:nvPr/>
+        </p:nvSpPr>
+        <p:spPr>
+          <a:xfrm>
+            <a:off x="548640" y="5486400"/>
+            <a:ext cx="5486400" cy="868680"/>
+          </a:xfrm>
+          <a:prstGeom prst="rect">
+            <a:avLst/>
+          </a:prstGeom>
+          <a:noFill/>
+          <a:ln/>
+        </p:spPr>
+        <p:txBody>
+          <a:bodyPr wrap="square" lIns="0" tIns="0" rIns="0" bIns="0" rtlCol="0" anchor="t"/>
+          <a:lstStyle/>
+          <a:p>
+            <a:pPr indent="0" marL="0">
+              <a:buNone/>
+            </a:pPr>
+            <a:r>
+              <a:rPr lang="en-US" sz="1500" i="1" dirty="0">
+                <a:solidFill>
+                  <a:srgbClr val="5B6B8C"/>
+                </a:solidFill>
+                <a:latin typeface="Calibri" pitchFamily="34" charset="0"/>
+                <a:ea typeface="Calibri" pitchFamily="34" charset="-122"/>
+                <a:cs typeface="Calibri" pitchFamily="34" charset="-120"/>
+              </a:rPr>
+              <a:t>Belege jede Aussage mit Zitat und Zeile (A, Z. … bzw. C, Z. …). Grundlage ist deine Matrix im Hefter.</a:t>
+            </a:r>
+            <a:endParaRPr lang="en-US" sz="1500" dirty="0"/>
+          </a:p>
+        </p:txBody>
+      </p:sp>
+      <p:sp>
+        <p:nvSpPr>
+          <p:cNvPr id="20" name="Shape 18"/>
           <p:cNvSpPr/>
           <p:nvPr/>
         </p:nvSpPr>
         <p:spPr>
           <a:xfrm>
-            <a:off x="548640" y="4434840"/>
-            <a:ext cx="11064240" cy="2057400"/>
+            <a:off x="6309360" y="2971800"/>
+            <a:ext cx="5303520" cy="3429000"/>
           </a:xfrm>
           <a:prstGeom prst="roundRect">
             <a:avLst>
-              <a:gd name="adj" fmla="val 3556"/>
+              <a:gd name="adj" fmla="val 2133"/>
             </a:avLst>
           </a:prstGeom>
           <a:solidFill>
@@ -3132,14 +3286,14 @@
       </p:sp>
       <p:sp>
         <p:nvSpPr>
-          <p:cNvPr id="18" name="Text 16"/>
-          <p:cNvSpPr txBox="1"/>
-          <p:nvPr/>
-        </p:nvSpPr>
-        <p:spPr>
-          <a:xfrm>
-            <a:off x="822960" y="4553712"/>
-            <a:ext cx="5486400" cy="411480"/>
+          <p:cNvPr id="21" name="Text 19"/>
+          <p:cNvSpPr txBox="1"/>
+          <p:nvPr/>
+        </p:nvSpPr>
+        <p:spPr>
+          <a:xfrm>
+            <a:off x="6537960" y="3063240"/>
+            <a:ext cx="4572000" cy="411480"/>
           </a:xfrm>
           <a:prstGeom prst="rect">
             <a:avLst/>
@@ -3155,7 +3309,7 @@
               <a:buNone/>
             </a:pPr>
             <a:r>
-              <a:rPr lang="en-US" sz="2000" b="1" dirty="0">
+              <a:rPr lang="en-US" sz="1900" b="1" dirty="0">
                 <a:solidFill>
                   <a:srgbClr val="E8A33D"/>
                 </a:solidFill>
@@ -3165,20 +3319,20 @@
               </a:rPr>
               <a:t>Satzbausteine</a:t>
             </a:r>
-            <a:endParaRPr lang="en-US" sz="2000" dirty="0"/>
-          </a:p>
-        </p:txBody>
-      </p:sp>
-      <p:sp>
-        <p:nvSpPr>
-          <p:cNvPr id="19" name="Text 17"/>
-          <p:cNvSpPr txBox="1"/>
-          <p:nvPr/>
-        </p:nvSpPr>
-        <p:spPr>
-          <a:xfrm>
-            <a:off x="822960" y="5029200"/>
-            <a:ext cx="10515600" cy="1371600"/>
+            <a:endParaRPr lang="en-US" sz="1900" dirty="0"/>
+          </a:p>
+        </p:txBody>
+      </p:sp>
+      <p:sp>
+        <p:nvSpPr>
+          <p:cNvPr id="22" name="Text 20"/>
+          <p:cNvSpPr txBox="1"/>
+          <p:nvPr/>
+        </p:nvSpPr>
+        <p:spPr>
+          <a:xfrm>
+            <a:off x="6537960" y="3520440"/>
+            <a:ext cx="4937760" cy="2788920"/>
           </a:xfrm>
           <a:prstGeom prst="rect">
             <a:avLst/>
@@ -3192,12 +3346,12 @@
           <a:p>
             <a:pPr indent="0" marL="0">
               <a:spcAft>
-                <a:spcPts val="400"/>
+                <a:spcPts val="300"/>
               </a:spcAft>
               <a:buNone/>
             </a:pPr>
             <a:r>
-              <a:rPr lang="en-US" sz="1800" i="1" dirty="0">
+              <a:rPr lang="en-US" sz="1500" i="1" dirty="0">
                 <a:solidFill>
                   <a:srgbClr val="1E2761"/>
                 </a:solidFill>
@@ -3205,9 +3359,129 @@
                 <a:ea typeface="Calibri" pitchFamily="34" charset="-122"/>
                 <a:cs typeface="Calibri" pitchFamily="34" charset="-120"/>
               </a:rPr>
-              <a:t>In seinem „Brief an den Vater“ (1919) …  ·  Indem der Vater …, sendet er …  ·  Dies zeigt sich in … (Z. …)  ·  Hinzu kommt, dass …  ·  Die Folge ist …  ·  Besonders deutlich wird dies, wenn …  ·  Insgesamt stützt die Stelle die These, weil …  ·  Allerdings …</a:t>
-            </a:r>
-            <a:endParaRPr lang="en-US" sz="1800" dirty="0"/>
+              <a:t>In seinem „Brief an den Vater“ (1919) …</a:t>
+            </a:r>
+            <a:endParaRPr lang="en-US" sz="1500" dirty="0"/>
+          </a:p>
+          <a:p>
+            <a:pPr indent="0" marL="0">
+              <a:spcAft>
+                <a:spcPts val="300"/>
+              </a:spcAft>
+              <a:buNone/>
+            </a:pPr>
+            <a:r>
+              <a:rPr lang="en-US" sz="1500" i="1" dirty="0">
+                <a:solidFill>
+                  <a:srgbClr val="1E2761"/>
+                </a:solidFill>
+                <a:latin typeface="Calibri" pitchFamily="34" charset="0"/>
+                <a:ea typeface="Calibri" pitchFamily="34" charset="-122"/>
+                <a:cs typeface="Calibri" pitchFamily="34" charset="-120"/>
+              </a:rPr>
+              <a:t>Indem der Vater …, sendet er …</a:t>
+            </a:r>
+            <a:endParaRPr lang="en-US" sz="1500" dirty="0"/>
+          </a:p>
+          <a:p>
+            <a:pPr indent="0" marL="0">
+              <a:spcAft>
+                <a:spcPts val="300"/>
+              </a:spcAft>
+              <a:buNone/>
+            </a:pPr>
+            <a:r>
+              <a:rPr lang="en-US" sz="1500" i="1" dirty="0">
+                <a:solidFill>
+                  <a:srgbClr val="1E2761"/>
+                </a:solidFill>
+                <a:latin typeface="Calibri" pitchFamily="34" charset="0"/>
+                <a:ea typeface="Calibri" pitchFamily="34" charset="-122"/>
+                <a:cs typeface="Calibri" pitchFamily="34" charset="-120"/>
+              </a:rPr>
+              <a:t>Dies zeigt sich in … (Z. …)</a:t>
+            </a:r>
+            <a:endParaRPr lang="en-US" sz="1500" dirty="0"/>
+          </a:p>
+          <a:p>
+            <a:pPr indent="0" marL="0">
+              <a:spcAft>
+                <a:spcPts val="300"/>
+              </a:spcAft>
+              <a:buNone/>
+            </a:pPr>
+            <a:r>
+              <a:rPr lang="en-US" sz="1500" i="1" dirty="0">
+                <a:solidFill>
+                  <a:srgbClr val="1E2761"/>
+                </a:solidFill>
+                <a:latin typeface="Calibri" pitchFamily="34" charset="0"/>
+                <a:ea typeface="Calibri" pitchFamily="34" charset="-122"/>
+                <a:cs typeface="Calibri" pitchFamily="34" charset="-120"/>
+              </a:rPr>
+              <a:t>Hinzu kommt, dass …  ·  Die Folge ist …</a:t>
+            </a:r>
+            <a:endParaRPr lang="en-US" sz="1500" dirty="0"/>
+          </a:p>
+          <a:p>
+            <a:pPr indent="0" marL="0">
+              <a:spcAft>
+                <a:spcPts val="300"/>
+              </a:spcAft>
+              <a:buNone/>
+            </a:pPr>
+            <a:r>
+              <a:rPr lang="en-US" sz="1500" i="1" dirty="0">
+                <a:solidFill>
+                  <a:srgbClr val="1E2761"/>
+                </a:solidFill>
+                <a:latin typeface="Calibri" pitchFamily="34" charset="0"/>
+                <a:ea typeface="Calibri" pitchFamily="34" charset="-122"/>
+                <a:cs typeface="Calibri" pitchFamily="34" charset="-120"/>
+              </a:rPr>
+              <a:t>Besonders deutlich wird dies, wenn …</a:t>
+            </a:r>
+            <a:endParaRPr lang="en-US" sz="1500" dirty="0"/>
+          </a:p>
+          <a:p>
+            <a:pPr indent="0" marL="0">
+              <a:spcAft>
+                <a:spcPts val="300"/>
+              </a:spcAft>
+              <a:buNone/>
+            </a:pPr>
+            <a:r>
+              <a:rPr lang="en-US" sz="1500" i="1" dirty="0">
+                <a:solidFill>
+                  <a:srgbClr val="1E2761"/>
+                </a:solidFill>
+                <a:latin typeface="Calibri" pitchFamily="34" charset="0"/>
+                <a:ea typeface="Calibri" pitchFamily="34" charset="-122"/>
+                <a:cs typeface="Calibri" pitchFamily="34" charset="-120"/>
+              </a:rPr>
+              <a:t>Insgesamt stützt die Stelle die These, weil …</a:t>
+            </a:r>
+            <a:endParaRPr lang="en-US" sz="1500" dirty="0"/>
+          </a:p>
+          <a:p>
+            <a:pPr indent="0" marL="0">
+              <a:spcAft>
+                <a:spcPts val="300"/>
+              </a:spcAft>
+              <a:buNone/>
+            </a:pPr>
+            <a:r>
+              <a:rPr lang="en-US" sz="1500" i="1" dirty="0">
+                <a:solidFill>
+                  <a:srgbClr val="1E2761"/>
+                </a:solidFill>
+                <a:latin typeface="Calibri" pitchFamily="34" charset="0"/>
+                <a:ea typeface="Calibri" pitchFamily="34" charset="-122"/>
+                <a:cs typeface="Calibri" pitchFamily="34" charset="-120"/>
+              </a:rPr>
+              <a:t>Allerdings …</a:t>
+            </a:r>
+            <a:endParaRPr lang="en-US" sz="1500" dirty="0"/>
           </a:p>
         </p:txBody>
       </p:sp>

</xml_diff>